<commit_message>
docs: añadir diagrama vista general
</commit_message>
<xml_diff>
--- a/Docu_TFG/Ignorar_git/Plantilla presentación proyecto DAM.pptx
+++ b/Docu_TFG/Ignorar_git/Plantilla presentación proyecto DAM.pptx
@@ -290,7 +290,7 @@
       <p15:sldGuideLst xmlns:p15="http://schemas.microsoft.com/office/powerpoint/2012/main"/>
     </p:ext>
     <p:ext uri="GoogleSlidesCustomDataVersion2">
-      <go:slidesCustomData xmlns="" xmlns:mc="http://schemas.openxmlformats.org/markup-compatibility/2006" xmlns:mv="urn:schemas-microsoft-com:mac:vml" xmlns:c="http://schemas.openxmlformats.org/drawingml/2006/chart" xmlns:dgm="http://schemas.openxmlformats.org/drawingml/2006/diagram" xmlns:o="urn:schemas-microsoft-com:office:office" xmlns:v="urn:schemas-microsoft-com:vml" xmlns:pvml="urn:schemas-microsoft-com:office:powerpoint" xmlns:com="http://schemas.openxmlformats.org/drawingml/2006/compatibility" xmlns:p14="http://schemas.microsoft.com/office/powerpoint/2010/main" xmlns:p15="http://schemas.microsoft.com/office/powerpoint/2012/main" xmlns:ahyp="http://schemas.microsoft.com/office/drawing/2018/hyperlinkcolor" xmlns:go="http://customooxmlschemas.google.com/" r:id="rId81" roundtripDataSignature="AMtx7mgXYiiB6cvLgKsaKvqMK5pPDh6IEw=="/>
+      <go:slidesCustomData xmlns:go="http://customooxmlschemas.google.com/" xmlns:ahyp="http://schemas.microsoft.com/office/drawing/2018/hyperlinkcolor" xmlns:p15="http://schemas.microsoft.com/office/powerpoint/2012/main" xmlns:p14="http://schemas.microsoft.com/office/powerpoint/2010/main" xmlns:com="http://schemas.openxmlformats.org/drawingml/2006/compatibility" xmlns:pvml="urn:schemas-microsoft-com:office:powerpoint" xmlns:v="urn:schemas-microsoft-com:vml" xmlns:o="urn:schemas-microsoft-com:office:office" xmlns:dgm="http://schemas.openxmlformats.org/drawingml/2006/diagram" xmlns:c="http://schemas.openxmlformats.org/drawingml/2006/chart" xmlns:mv="urn:schemas-microsoft-com:mac:vml" xmlns:mc="http://schemas.openxmlformats.org/markup-compatibility/2006" xmlns="" r:id="rId81" roundtripDataSignature="AMtx7mgXYiiB6cvLgKsaKvqMK5pPDh6IEw=="/>
     </p:ext>
   </p:extLst>
 </p:presentation>
@@ -1632,14 +1632,6 @@
 <file path=ppt/slideLayouts/slideLayout1.xml><?xml version="1.0" encoding="utf-8"?>
 <p:sldLayout xmlns:a="http://schemas.openxmlformats.org/drawingml/2006/main" xmlns:r="http://schemas.openxmlformats.org/officeDocument/2006/relationships" xmlns:p="http://schemas.openxmlformats.org/presentationml/2006/main" matchingName="01.Portada" type="title">
   <p:cSld name="TITLE">
-    <p:bg>
-      <p:bgPr>
-        <a:solidFill>
-          <a:schemeClr val="dk1"/>
-        </a:solidFill>
-        <a:effectLst/>
-      </p:bgPr>
-    </p:bg>
     <p:spTree>
       <p:nvGrpSpPr>
         <p:cNvPr id="1" name="Shape 8"/>
@@ -2164,14 +2156,6 @@
 <file path=ppt/slideLayouts/slideLayout3.xml><?xml version="1.0" encoding="utf-8"?>
 <p:sldLayout xmlns:a="http://schemas.openxmlformats.org/drawingml/2006/main" xmlns:r="http://schemas.openxmlformats.org/officeDocument/2006/relationships" xmlns:p="http://schemas.openxmlformats.org/presentationml/2006/main" matchingName="Numbers and text" userDrawn="1">
   <p:cSld name="CUSTOM_3">
-    <p:bg>
-      <p:bgPr>
-        <a:solidFill>
-          <a:schemeClr val="accent3"/>
-        </a:solidFill>
-        <a:effectLst/>
-      </p:bgPr>
-    </p:bg>
     <p:spTree>
       <p:nvGrpSpPr>
         <p:cNvPr id="1" name="Shape 136"/>
@@ -4434,7 +4418,7 @@
     <p:bg>
       <p:bgPr>
         <a:solidFill>
-          <a:schemeClr val="lt1"/>
+          <a:srgbClr val="FADED3"/>
         </a:solidFill>
         <a:effectLst/>
       </p:bgPr>
@@ -6308,6 +6292,13 @@
           <a:ln>
             <a:noFill/>
           </a:ln>
+          <a:effectLst>
+            <a:outerShdw blurRad="50800" dist="38100" dir="2700000" algn="tl" rotWithShape="0">
+              <a:srgbClr val="094A55">
+                <a:alpha val="90000"/>
+              </a:srgbClr>
+            </a:outerShdw>
+          </a:effectLst>
         </p:spPr>
         <p:txBody>
           <a:bodyPr wrap="square" lIns="274320" tIns="228600" rIns="228600" bIns="228600" rtlCol="0" anchor="t"/>
@@ -6445,6 +6436,13 @@
           <a:ln>
             <a:noFill/>
           </a:ln>
+          <a:effectLst>
+            <a:outerShdw blurRad="50800" dist="38100" dir="2700000" algn="tl" rotWithShape="0">
+              <a:srgbClr val="094A55">
+                <a:alpha val="90000"/>
+              </a:srgbClr>
+            </a:outerShdw>
+          </a:effectLst>
         </p:spPr>
         <p:txBody>
           <a:bodyPr wrap="square" lIns="274320" tIns="228600" rIns="228600" bIns="228600" rtlCol="0" anchor="t"/>
@@ -6751,6 +6749,13 @@
           <a:ln>
             <a:noFill/>
           </a:ln>
+          <a:effectLst>
+            <a:outerShdw blurRad="50800" dist="38100" dir="2700000" algn="tl" rotWithShape="0">
+              <a:srgbClr val="094A55">
+                <a:alpha val="90000"/>
+              </a:srgbClr>
+            </a:outerShdw>
+          </a:effectLst>
         </p:spPr>
         <p:txBody>
           <a:bodyPr wrap="square" lIns="152400" tIns="152400" rIns="152400" bIns="152400" rtlCol="0" anchor="t"/>
@@ -6818,6 +6823,13 @@
           <a:ln>
             <a:noFill/>
           </a:ln>
+          <a:effectLst>
+            <a:outerShdw blurRad="50800" dist="38100" dir="2700000" algn="tl" rotWithShape="0">
+              <a:srgbClr val="094A55">
+                <a:alpha val="90000"/>
+              </a:srgbClr>
+            </a:outerShdw>
+          </a:effectLst>
         </p:spPr>
         <p:txBody>
           <a:bodyPr wrap="square" lIns="152400" tIns="152400" rIns="152400" bIns="152400" rtlCol="0" anchor="t"/>
@@ -6885,6 +6897,13 @@
           <a:ln>
             <a:noFill/>
           </a:ln>
+          <a:effectLst>
+            <a:outerShdw blurRad="50800" dist="38100" dir="2700000" algn="tl" rotWithShape="0">
+              <a:srgbClr val="094A55">
+                <a:alpha val="90000"/>
+              </a:srgbClr>
+            </a:outerShdw>
+          </a:effectLst>
         </p:spPr>
         <p:txBody>
           <a:bodyPr wrap="square" lIns="152400" tIns="152400" rIns="152400" bIns="152400" rtlCol="0" anchor="t"/>
@@ -6952,6 +6971,13 @@
           <a:ln>
             <a:noFill/>
           </a:ln>
+          <a:effectLst>
+            <a:outerShdw blurRad="50800" dist="38100" dir="2700000" algn="tl" rotWithShape="0">
+              <a:srgbClr val="094A55">
+                <a:alpha val="90000"/>
+              </a:srgbClr>
+            </a:outerShdw>
+          </a:effectLst>
         </p:spPr>
         <p:txBody>
           <a:bodyPr wrap="square" lIns="152400" tIns="152400" rIns="152400" bIns="152400" rtlCol="0" anchor="t"/>
@@ -7019,6 +7045,13 @@
           <a:ln>
             <a:noFill/>
           </a:ln>
+          <a:effectLst>
+            <a:outerShdw blurRad="50800" dist="38100" dir="2700000" algn="tl" rotWithShape="0">
+              <a:srgbClr val="094A55">
+                <a:alpha val="90000"/>
+              </a:srgbClr>
+            </a:outerShdw>
+          </a:effectLst>
         </p:spPr>
         <p:txBody>
           <a:bodyPr wrap="square" lIns="152400" tIns="152400" rIns="152400" bIns="152400" rtlCol="0" anchor="t"/>
@@ -7086,6 +7119,13 @@
           <a:ln>
             <a:noFill/>
           </a:ln>
+          <a:effectLst>
+            <a:outerShdw blurRad="50800" dist="38100" dir="2700000" algn="tl" rotWithShape="0">
+              <a:srgbClr val="094A55">
+                <a:alpha val="90000"/>
+              </a:srgbClr>
+            </a:outerShdw>
+          </a:effectLst>
         </p:spPr>
         <p:txBody>
           <a:bodyPr wrap="square" lIns="152400" tIns="152400" rIns="152400" bIns="152400" rtlCol="0" anchor="t"/>
@@ -7153,6 +7193,13 @@
           <a:ln>
             <a:noFill/>
           </a:ln>
+          <a:effectLst>
+            <a:outerShdw blurRad="50800" dist="38100" dir="2700000" algn="tl" rotWithShape="0">
+              <a:srgbClr val="094A55">
+                <a:alpha val="90000"/>
+              </a:srgbClr>
+            </a:outerShdw>
+          </a:effectLst>
         </p:spPr>
         <p:txBody>
           <a:bodyPr wrap="square" lIns="152400" tIns="152400" rIns="152400" bIns="152400" rtlCol="0" anchor="t"/>
@@ -7220,6 +7267,13 @@
           <a:ln>
             <a:noFill/>
           </a:ln>
+          <a:effectLst>
+            <a:outerShdw blurRad="50800" dist="38100" dir="2700000" algn="tl" rotWithShape="0">
+              <a:srgbClr val="094A55">
+                <a:alpha val="90000"/>
+              </a:srgbClr>
+            </a:outerShdw>
+          </a:effectLst>
         </p:spPr>
         <p:txBody>
           <a:bodyPr wrap="square" lIns="152400" tIns="152400" rIns="152400" bIns="152400" rtlCol="0" anchor="t"/>
@@ -7410,6 +7464,13 @@
           <a:ln>
             <a:noFill/>
           </a:ln>
+          <a:effectLst>
+            <a:outerShdw blurRad="50800" dist="38100" dir="2700000" algn="tl" rotWithShape="0">
+              <a:srgbClr val="094A55">
+                <a:alpha val="90000"/>
+              </a:srgbClr>
+            </a:outerShdw>
+          </a:effectLst>
         </p:spPr>
         <p:txBody>
           <a:bodyPr wrap="square" lIns="228600" tIns="228600" rIns="228600" bIns="228600" rtlCol="0" anchor="t"/>
@@ -7503,6 +7564,13 @@
           <a:ln>
             <a:noFill/>
           </a:ln>
+          <a:effectLst>
+            <a:outerShdw blurRad="50800" dist="38100" dir="2700000" algn="tl" rotWithShape="0">
+              <a:srgbClr val="094A55">
+                <a:alpha val="90000"/>
+              </a:srgbClr>
+            </a:outerShdw>
+          </a:effectLst>
         </p:spPr>
         <p:txBody>
           <a:bodyPr wrap="square" lIns="152400" tIns="152400" rIns="152400" bIns="152400" rtlCol="0" anchor="t"/>
@@ -7572,6 +7640,13 @@
           <a:ln>
             <a:noFill/>
           </a:ln>
+          <a:effectLst>
+            <a:outerShdw blurRad="50800" dist="38100" dir="2700000" algn="tl" rotWithShape="0">
+              <a:srgbClr val="094A55">
+                <a:alpha val="90000"/>
+              </a:srgbClr>
+            </a:outerShdw>
+          </a:effectLst>
         </p:spPr>
         <p:txBody>
           <a:bodyPr wrap="square" lIns="152400" tIns="152400" rIns="152400" bIns="152400" rtlCol="0" anchor="t"/>
@@ -7641,6 +7716,13 @@
           <a:ln>
             <a:noFill/>
           </a:ln>
+          <a:effectLst>
+            <a:outerShdw blurRad="50800" dist="38100" dir="2700000" algn="tl" rotWithShape="0">
+              <a:srgbClr val="094A55">
+                <a:alpha val="90000"/>
+              </a:srgbClr>
+            </a:outerShdw>
+          </a:effectLst>
         </p:spPr>
         <p:txBody>
           <a:bodyPr wrap="square" lIns="152400" tIns="152400" rIns="152400" bIns="152400" rtlCol="0" anchor="t"/>
@@ -7710,6 +7792,13 @@
           <a:ln>
             <a:noFill/>
           </a:ln>
+          <a:effectLst>
+            <a:outerShdw blurRad="50800" dist="38100" dir="2700000" algn="tl" rotWithShape="0">
+              <a:srgbClr val="094A55">
+                <a:alpha val="90000"/>
+              </a:srgbClr>
+            </a:outerShdw>
+          </a:effectLst>
         </p:spPr>
         <p:txBody>
           <a:bodyPr wrap="square" lIns="152400" tIns="152400" rIns="152400" bIns="152400" rtlCol="0" anchor="t"/>
@@ -7894,6 +7983,13 @@
           <a:ln>
             <a:noFill/>
           </a:ln>
+          <a:effectLst>
+            <a:outerShdw blurRad="50800" dist="38100" dir="2700000" algn="tl" rotWithShape="0">
+              <a:srgbClr val="094A55">
+                <a:alpha val="90000"/>
+              </a:srgbClr>
+            </a:outerShdw>
+          </a:effectLst>
         </p:spPr>
         <p:txBody>
           <a:bodyPr wrap="square" lIns="228600" tIns="182880" rIns="228600" bIns="182880" rtlCol="0" anchor="ctr"/>
@@ -7998,6 +8094,13 @@
           <a:ln>
             <a:noFill/>
           </a:ln>
+          <a:effectLst>
+            <a:outerShdw blurRad="50800" dist="38100" dir="2700000" algn="tl" rotWithShape="0">
+              <a:srgbClr val="094A55">
+                <a:alpha val="90000"/>
+              </a:srgbClr>
+            </a:outerShdw>
+          </a:effectLst>
         </p:spPr>
         <p:txBody>
           <a:bodyPr wrap="square" lIns="91440" tIns="91440" rIns="91440" bIns="91440" rtlCol="0" anchor="ctr"/>
@@ -8052,6 +8155,13 @@
           <a:ln>
             <a:noFill/>
           </a:ln>
+          <a:effectLst>
+            <a:outerShdw blurRad="50800" dist="38100" dir="2700000" algn="tl" rotWithShape="0">
+              <a:srgbClr val="094A55">
+                <a:alpha val="90000"/>
+              </a:srgbClr>
+            </a:outerShdw>
+          </a:effectLst>
         </p:spPr>
         <p:txBody>
           <a:bodyPr wrap="square" lIns="182880" tIns="152400" rIns="182880" bIns="152400" rtlCol="0" anchor="ctr"/>
@@ -8106,6 +8216,13 @@
           <a:ln>
             <a:noFill/>
           </a:ln>
+          <a:effectLst>
+            <a:outerShdw blurRad="50800" dist="38100" dir="2700000" algn="tl" rotWithShape="0">
+              <a:srgbClr val="094A55">
+                <a:alpha val="90000"/>
+              </a:srgbClr>
+            </a:outerShdw>
+          </a:effectLst>
         </p:spPr>
         <p:txBody>
           <a:bodyPr wrap="square" lIns="182880" tIns="182880" rIns="182880" bIns="182880" rtlCol="0" anchor="t"/>
@@ -8173,6 +8290,13 @@
           <a:ln>
             <a:noFill/>
           </a:ln>
+          <a:effectLst>
+            <a:outerShdw blurRad="50800" dist="38100" dir="2700000" algn="tl" rotWithShape="0">
+              <a:srgbClr val="094A55">
+                <a:alpha val="90000"/>
+              </a:srgbClr>
+            </a:outerShdw>
+          </a:effectLst>
         </p:spPr>
         <p:txBody>
           <a:bodyPr wrap="square" lIns="182880" tIns="182880" rIns="182880" bIns="182880" rtlCol="0" anchor="t"/>
@@ -8242,6 +8366,13 @@
           <a:ln>
             <a:noFill/>
           </a:ln>
+          <a:effectLst>
+            <a:outerShdw blurRad="50800" dist="38100" dir="2700000" algn="tl" rotWithShape="0">
+              <a:srgbClr val="094A55">
+                <a:alpha val="90000"/>
+              </a:srgbClr>
+            </a:outerShdw>
+          </a:effectLst>
         </p:spPr>
         <p:txBody>
           <a:bodyPr wrap="square" lIns="182880" tIns="182880" rIns="182880" bIns="182880" rtlCol="0" anchor="t"/>
@@ -8332,6 +8463,13 @@
             <a:avLst/>
           </a:prstGeom>
           <a:noFill/>
+          <a:effectLst>
+            <a:outerShdw blurRad="50800" dist="38100" dir="2700000" algn="tl" rotWithShape="0">
+              <a:srgbClr val="094A55">
+                <a:alpha val="90000"/>
+              </a:srgbClr>
+            </a:outerShdw>
+          </a:effectLst>
         </p:spPr>
         <p:txBody>
           <a:bodyPr wrap="square" rtlCol="0" anchor="t"/>
@@ -9120,6 +9258,13 @@
           <a:ln>
             <a:noFill/>
           </a:ln>
+          <a:effectLst>
+            <a:outerShdw blurRad="50800" dist="38100" dir="2700000" algn="tl" rotWithShape="0">
+              <a:srgbClr val="094A55">
+                <a:alpha val="90000"/>
+              </a:srgbClr>
+            </a:outerShdw>
+          </a:effectLst>
         </p:spPr>
         <p:txBody>
           <a:bodyPr wrap="square" lIns="228600" tIns="182880" rIns="228600" bIns="182880" rtlCol="0" anchor="ctr"/>
@@ -9187,6 +9332,13 @@
           <a:ln>
             <a:noFill/>
           </a:ln>
+          <a:effectLst>
+            <a:outerShdw blurRad="50800" dist="38100" dir="2700000" algn="tl" rotWithShape="0">
+              <a:srgbClr val="094A55">
+                <a:alpha val="90000"/>
+              </a:srgbClr>
+            </a:outerShdw>
+          </a:effectLst>
         </p:spPr>
         <p:txBody>
           <a:bodyPr wrap="square" lIns="228600" tIns="228600" rIns="228600" bIns="228600" rtlCol="0" anchor="t"/>
@@ -9312,6 +9464,13 @@
           <a:ln>
             <a:noFill/>
           </a:ln>
+          <a:effectLst>
+            <a:outerShdw blurRad="50800" dist="38100" dir="2700000" algn="tl" rotWithShape="0">
+              <a:srgbClr val="094A55">
+                <a:alpha val="90000"/>
+              </a:srgbClr>
+            </a:outerShdw>
+          </a:effectLst>
         </p:spPr>
         <p:txBody>
           <a:bodyPr wrap="square" lIns="228600" tIns="182880" rIns="228600" bIns="182880" rtlCol="0" anchor="t"/>
@@ -9382,6 +9541,13 @@
           <a:ln>
             <a:noFill/>
           </a:ln>
+          <a:effectLst>
+            <a:outerShdw blurRad="50800" dist="38100" dir="2700000" algn="tl" rotWithShape="0">
+              <a:srgbClr val="094A55">
+                <a:alpha val="90000"/>
+              </a:srgbClr>
+            </a:outerShdw>
+          </a:effectLst>
         </p:spPr>
         <p:txBody>
           <a:bodyPr wrap="square" lIns="228600" tIns="182880" rIns="228600" bIns="182880" rtlCol="0" anchor="t"/>
@@ -9452,6 +9618,13 @@
           <a:ln>
             <a:noFill/>
           </a:ln>
+          <a:effectLst>
+            <a:outerShdw blurRad="50800" dist="38100" dir="2700000" algn="tl" rotWithShape="0">
+              <a:srgbClr val="094A55">
+                <a:alpha val="90000"/>
+              </a:srgbClr>
+            </a:outerShdw>
+          </a:effectLst>
         </p:spPr>
         <p:txBody>
           <a:bodyPr wrap="square" lIns="228600" tIns="182880" rIns="228600" bIns="182880" rtlCol="0" anchor="t"/>
@@ -9601,6 +9774,13 @@
           <a:ln>
             <a:noFill/>
           </a:ln>
+          <a:effectLst>
+            <a:outerShdw blurRad="50800" dist="38100" dir="2700000" algn="tl" rotWithShape="0">
+              <a:srgbClr val="094A55">
+                <a:alpha val="90000"/>
+              </a:srgbClr>
+            </a:outerShdw>
+          </a:effectLst>
         </p:spPr>
         <p:txBody>
           <a:bodyPr wrap="square" lIns="182880" tIns="91440" rIns="182880" bIns="91440" rtlCol="0" anchor="ctr"/>
@@ -9655,6 +9835,13 @@
           <a:ln>
             <a:noFill/>
           </a:ln>
+          <a:effectLst>
+            <a:outerShdw blurRad="50800" dist="38100" dir="2700000" algn="tl" rotWithShape="0">
+              <a:srgbClr val="094A55">
+                <a:alpha val="90000"/>
+              </a:srgbClr>
+            </a:outerShdw>
+          </a:effectLst>
         </p:spPr>
         <p:txBody>
           <a:bodyPr wrap="square" lIns="182880" tIns="91440" rIns="182880" bIns="91440" rtlCol="0" anchor="ctr"/>
@@ -9709,6 +9896,13 @@
           <a:ln>
             <a:noFill/>
           </a:ln>
+          <a:effectLst>
+            <a:outerShdw blurRad="50800" dist="38100" dir="2700000" algn="tl" rotWithShape="0">
+              <a:srgbClr val="094A55">
+                <a:alpha val="90000"/>
+              </a:srgbClr>
+            </a:outerShdw>
+          </a:effectLst>
         </p:spPr>
         <p:txBody>
           <a:bodyPr wrap="square" lIns="182880" tIns="91440" rIns="182880" bIns="91440" rtlCol="0" anchor="ctr"/>
@@ -9763,6 +9957,13 @@
           <a:ln>
             <a:noFill/>
           </a:ln>
+          <a:effectLst>
+            <a:outerShdw blurRad="50800" dist="38100" dir="2700000" algn="tl" rotWithShape="0">
+              <a:srgbClr val="094A55">
+                <a:alpha val="90000"/>
+              </a:srgbClr>
+            </a:outerShdw>
+          </a:effectLst>
         </p:spPr>
         <p:txBody>
           <a:bodyPr wrap="square" lIns="182880" tIns="91440" rIns="182880" bIns="91440" rtlCol="0" anchor="ctr"/>
@@ -9817,6 +10018,13 @@
           <a:ln>
             <a:noFill/>
           </a:ln>
+          <a:effectLst>
+            <a:outerShdw blurRad="50800" dist="38100" dir="2700000" algn="tl" rotWithShape="0">
+              <a:srgbClr val="094A55">
+                <a:alpha val="90000"/>
+              </a:srgbClr>
+            </a:outerShdw>
+          </a:effectLst>
         </p:spPr>
         <p:txBody>
           <a:bodyPr wrap="square" lIns="182880" tIns="91440" rIns="182880" bIns="91440" rtlCol="0" anchor="ctr"/>
@@ -9871,6 +10079,13 @@
           <a:ln>
             <a:noFill/>
           </a:ln>
+          <a:effectLst>
+            <a:outerShdw blurRad="50800" dist="38100" dir="2700000" algn="tl" rotWithShape="0">
+              <a:srgbClr val="094A55">
+                <a:alpha val="90000"/>
+              </a:srgbClr>
+            </a:outerShdw>
+          </a:effectLst>
         </p:spPr>
         <p:txBody>
           <a:bodyPr wrap="square" lIns="182880" tIns="91440" rIns="182880" bIns="91440" rtlCol="0" anchor="ctr"/>
@@ -9925,6 +10140,13 @@
           <a:ln>
             <a:noFill/>
           </a:ln>
+          <a:effectLst>
+            <a:outerShdw blurRad="50800" dist="38100" dir="2700000" algn="tl" rotWithShape="0">
+              <a:srgbClr val="094A55">
+                <a:alpha val="90000"/>
+              </a:srgbClr>
+            </a:outerShdw>
+          </a:effectLst>
         </p:spPr>
         <p:txBody>
           <a:bodyPr wrap="square" lIns="182880" tIns="91440" rIns="182880" bIns="91440" rtlCol="0" anchor="ctr"/>
@@ -9979,6 +10201,13 @@
           <a:ln>
             <a:noFill/>
           </a:ln>
+          <a:effectLst>
+            <a:outerShdw blurRad="50800" dist="38100" dir="2700000" algn="tl" rotWithShape="0">
+              <a:srgbClr val="094A55">
+                <a:alpha val="90000"/>
+              </a:srgbClr>
+            </a:outerShdw>
+          </a:effectLst>
         </p:spPr>
         <p:txBody>
           <a:bodyPr wrap="square" lIns="274320" tIns="228600" rIns="274320" bIns="228600" rtlCol="0" anchor="t"/>
@@ -10162,23 +10391,7 @@
                   <a:schemeClr val="accent2"/>
                 </a:solidFill>
               </a:rPr>
-              <a:t>Dispositivo físico · </a:t>
-            </a:r>
-            <a:r>
-              <a:rPr lang="es-ES" sz="1800">
-                <a:solidFill>
-                  <a:schemeClr val="accent2"/>
-                </a:solidFill>
-              </a:rPr>
-              <a:t>Android 16 </a:t>
-            </a:r>
-            <a:r>
-              <a:rPr lang="es-ES" sz="1800" dirty="0">
-                <a:solidFill>
-                  <a:schemeClr val="accent2"/>
-                </a:solidFill>
-              </a:rPr>
-              <a:t>· Offline-first</a:t>
+              <a:t>Dispositivo físico · Android 16 · Offline-first</a:t>
             </a:r>
           </a:p>
         </p:txBody>
@@ -10904,6 +11117,13 @@
           <a:ln>
             <a:noFill/>
           </a:ln>
+          <a:effectLst>
+            <a:outerShdw blurRad="50800" dist="38100" dir="2700000" algn="tl" rotWithShape="0">
+              <a:srgbClr val="094A55">
+                <a:alpha val="90000"/>
+              </a:srgbClr>
+            </a:outerShdw>
+          </a:effectLst>
         </p:spPr>
         <p:txBody>
           <a:bodyPr wrap="square" lIns="274320" tIns="228600" rIns="228600" bIns="228600" rtlCol="0" anchor="t"/>
@@ -11022,6 +11242,13 @@
           <a:ln>
             <a:noFill/>
           </a:ln>
+          <a:effectLst>
+            <a:outerShdw blurRad="50800" dist="38100" dir="2700000" algn="tl" rotWithShape="0">
+              <a:srgbClr val="094A55">
+                <a:alpha val="90000"/>
+              </a:srgbClr>
+            </a:outerShdw>
+          </a:effectLst>
         </p:spPr>
         <p:txBody>
           <a:bodyPr wrap="square" lIns="274320" tIns="228600" rIns="228600" bIns="228600" rtlCol="0" anchor="t"/>
@@ -11154,6 +11381,13 @@
             <a:avLst/>
           </a:prstGeom>
           <a:noFill/>
+          <a:effectLst>
+            <a:outerShdw blurRad="50800" dist="38100" dir="2700000" algn="tl" rotWithShape="0">
+              <a:prstClr val="black">
+                <a:alpha val="40000"/>
+              </a:prstClr>
+            </a:outerShdw>
+          </a:effectLst>
         </p:spPr>
         <p:txBody>
           <a:bodyPr wrap="square" rtlCol="0" anchor="t"/>
@@ -11168,7 +11402,15 @@
                   <a:schemeClr val="dk2"/>
                 </a:solidFill>
               </a:rPr>
-              <a:t>Índice de la presentación</a:t>
+              <a:t>Índice de la </a:t>
+            </a:r>
+            <a:r>
+              <a:rPr lang="es-ES" sz="3200" b="1" dirty="0">
+                <a:solidFill>
+                  <a:schemeClr val="dk2"/>
+                </a:solidFill>
+              </a:rPr>
+              <a:t>presentación</a:t>
             </a:r>
           </a:p>
         </p:txBody>
@@ -11195,6 +11437,13 @@
           <a:ln>
             <a:noFill/>
           </a:ln>
+          <a:effectLst>
+            <a:outerShdw blurRad="50800" dist="38100" dir="2700000" algn="tl" rotWithShape="0">
+              <a:srgbClr val="094A55">
+                <a:alpha val="90000"/>
+              </a:srgbClr>
+            </a:outerShdw>
+          </a:effectLst>
         </p:spPr>
         <p:txBody>
           <a:bodyPr wrap="square" lIns="91440" tIns="45720" rIns="91440" bIns="45720" rtlCol="0" anchor="ctr"/>
@@ -11244,6 +11493,13 @@
           <a:ln>
             <a:noFill/>
           </a:ln>
+          <a:effectLst>
+            <a:outerShdw blurRad="50800" dist="38100" dir="2700000" algn="tl" rotWithShape="0">
+              <a:srgbClr val="094A55">
+                <a:alpha val="90000"/>
+              </a:srgbClr>
+            </a:outerShdw>
+          </a:effectLst>
         </p:spPr>
         <p:txBody>
           <a:bodyPr wrap="square" lIns="91440" tIns="45720" rIns="91440" bIns="45720" rtlCol="0" anchor="ctr"/>
@@ -11293,6 +11549,13 @@
           <a:ln>
             <a:noFill/>
           </a:ln>
+          <a:effectLst>
+            <a:outerShdw blurRad="50800" dist="38100" dir="2700000" algn="tl" rotWithShape="0">
+              <a:srgbClr val="094A55">
+                <a:alpha val="90000"/>
+              </a:srgbClr>
+            </a:outerShdw>
+          </a:effectLst>
         </p:spPr>
         <p:txBody>
           <a:bodyPr wrap="square" lIns="91440" tIns="45720" rIns="91440" bIns="45720" rtlCol="0" anchor="ctr"/>
@@ -11342,6 +11605,13 @@
           <a:ln>
             <a:noFill/>
           </a:ln>
+          <a:effectLst>
+            <a:outerShdw blurRad="50800" dist="38100" dir="2700000" algn="tl" rotWithShape="0">
+              <a:srgbClr val="094A55">
+                <a:alpha val="90000"/>
+              </a:srgbClr>
+            </a:outerShdw>
+          </a:effectLst>
         </p:spPr>
         <p:txBody>
           <a:bodyPr wrap="square" lIns="91440" tIns="45720" rIns="91440" bIns="45720" rtlCol="0" anchor="ctr"/>
@@ -11391,6 +11661,13 @@
           <a:ln>
             <a:noFill/>
           </a:ln>
+          <a:effectLst>
+            <a:outerShdw blurRad="50800" dist="38100" dir="2700000" algn="tl" rotWithShape="0">
+              <a:srgbClr val="094A55">
+                <a:alpha val="90000"/>
+              </a:srgbClr>
+            </a:outerShdw>
+          </a:effectLst>
         </p:spPr>
         <p:txBody>
           <a:bodyPr wrap="square" lIns="91440" tIns="45720" rIns="91440" bIns="45720" rtlCol="0" anchor="ctr"/>
@@ -11440,6 +11717,13 @@
           <a:ln>
             <a:noFill/>
           </a:ln>
+          <a:effectLst>
+            <a:outerShdw blurRad="50800" dist="38100" dir="2700000" algn="tl" rotWithShape="0">
+              <a:srgbClr val="094A55">
+                <a:alpha val="90000"/>
+              </a:srgbClr>
+            </a:outerShdw>
+          </a:effectLst>
         </p:spPr>
         <p:txBody>
           <a:bodyPr wrap="square" lIns="91440" tIns="45720" rIns="91440" bIns="45720" rtlCol="0" anchor="ctr"/>
@@ -11512,6 +11796,13 @@
             <a:avLst/>
           </a:prstGeom>
           <a:noFill/>
+          <a:effectLst>
+            <a:outerShdw blurRad="50800" dist="38100" dir="2700000" algn="tl" rotWithShape="0">
+              <a:srgbClr val="094A55">
+                <a:alpha val="90000"/>
+              </a:srgbClr>
+            </a:outerShdw>
+          </a:effectLst>
         </p:spPr>
         <p:txBody>
           <a:bodyPr wrap="square" rtlCol="0" anchor="t"/>
@@ -11553,6 +11844,13 @@
           <a:ln>
             <a:noFill/>
           </a:ln>
+          <a:effectLst>
+            <a:outerShdw blurRad="50800" dist="38100" dir="2700000" algn="tl" rotWithShape="0">
+              <a:srgbClr val="094A55">
+                <a:alpha val="90000"/>
+              </a:srgbClr>
+            </a:outerShdw>
+          </a:effectLst>
         </p:spPr>
         <p:txBody>
           <a:bodyPr wrap="square" lIns="91440" tIns="91440" rIns="91440" bIns="91440" rtlCol="0" anchor="ctr"/>
@@ -11607,6 +11905,13 @@
           <a:ln>
             <a:noFill/>
           </a:ln>
+          <a:effectLst>
+            <a:outerShdw blurRad="50800" dist="38100" dir="2700000" algn="tl" rotWithShape="0">
+              <a:srgbClr val="094A55">
+                <a:alpha val="90000"/>
+              </a:srgbClr>
+            </a:outerShdw>
+          </a:effectLst>
         </p:spPr>
         <p:txBody>
           <a:bodyPr wrap="square" lIns="228600" tIns="182880" rIns="228600" bIns="182880" rtlCol="0" anchor="ctr"/>
@@ -11661,6 +11966,13 @@
           <a:ln>
             <a:noFill/>
           </a:ln>
+          <a:effectLst>
+            <a:outerShdw blurRad="50800" dist="38100" dir="2700000" algn="tl" rotWithShape="0">
+              <a:srgbClr val="094A55">
+                <a:alpha val="90000"/>
+              </a:srgbClr>
+            </a:outerShdw>
+          </a:effectLst>
         </p:spPr>
         <p:txBody>
           <a:bodyPr wrap="square" lIns="228600" tIns="228600" rIns="228600" bIns="228600" rtlCol="0" anchor="t"/>
@@ -11754,6 +12066,13 @@
           <a:ln>
             <a:noFill/>
           </a:ln>
+          <a:effectLst>
+            <a:outerShdw blurRad="50800" dist="38100" dir="2700000" algn="tl" rotWithShape="0">
+              <a:srgbClr val="094A55">
+                <a:alpha val="90000"/>
+              </a:srgbClr>
+            </a:outerShdw>
+          </a:effectLst>
         </p:spPr>
         <p:txBody>
           <a:bodyPr wrap="square" lIns="228600" tIns="228600" rIns="228600" bIns="228600" rtlCol="0" anchor="t"/>
@@ -11860,6 +12179,13 @@
             <a:avLst/>
           </a:prstGeom>
           <a:noFill/>
+          <a:effectLst>
+            <a:outerShdw blurRad="50800" dist="38100" dir="2700000" algn="tl" rotWithShape="0">
+              <a:srgbClr val="094A55">
+                <a:alpha val="90000"/>
+              </a:srgbClr>
+            </a:outerShdw>
+          </a:effectLst>
         </p:spPr>
         <p:txBody>
           <a:bodyPr wrap="square" rtlCol="0" anchor="t"/>
@@ -11901,6 +12227,13 @@
           <a:ln>
             <a:noFill/>
           </a:ln>
+          <a:effectLst>
+            <a:outerShdw blurRad="50800" dist="38100" dir="2700000" algn="tl" rotWithShape="0">
+              <a:srgbClr val="094A55">
+                <a:alpha val="90000"/>
+              </a:srgbClr>
+            </a:outerShdw>
+          </a:effectLst>
         </p:spPr>
         <p:txBody>
           <a:bodyPr wrap="square" lIns="152400" tIns="152400" rIns="152400" bIns="152400" rtlCol="0" anchor="t"/>
@@ -11968,6 +12301,13 @@
           <a:ln>
             <a:noFill/>
           </a:ln>
+          <a:effectLst>
+            <a:outerShdw blurRad="50800" dist="38100" dir="2700000" algn="tl" rotWithShape="0">
+              <a:srgbClr val="094A55">
+                <a:alpha val="90000"/>
+              </a:srgbClr>
+            </a:outerShdw>
+          </a:effectLst>
         </p:spPr>
         <p:txBody>
           <a:bodyPr wrap="square" lIns="152400" tIns="152400" rIns="152400" bIns="152400" rtlCol="0" anchor="t"/>
@@ -12035,6 +12375,13 @@
           <a:ln>
             <a:noFill/>
           </a:ln>
+          <a:effectLst>
+            <a:outerShdw blurRad="50800" dist="38100" dir="2700000" algn="tl" rotWithShape="0">
+              <a:srgbClr val="094A55">
+                <a:alpha val="90000"/>
+              </a:srgbClr>
+            </a:outerShdw>
+          </a:effectLst>
         </p:spPr>
         <p:txBody>
           <a:bodyPr wrap="square" lIns="152400" tIns="152400" rIns="152400" bIns="152400" rtlCol="0" anchor="t"/>
@@ -12102,6 +12449,13 @@
           <a:ln>
             <a:noFill/>
           </a:ln>
+          <a:effectLst>
+            <a:outerShdw blurRad="50800" dist="38100" dir="2700000" algn="tl" rotWithShape="0">
+              <a:srgbClr val="094A55">
+                <a:alpha val="90000"/>
+              </a:srgbClr>
+            </a:outerShdw>
+          </a:effectLst>
         </p:spPr>
         <p:txBody>
           <a:bodyPr wrap="square" lIns="152400" tIns="152400" rIns="152400" bIns="152400" rtlCol="0" anchor="t"/>
@@ -12169,6 +12523,13 @@
           <a:ln>
             <a:noFill/>
           </a:ln>
+          <a:effectLst>
+            <a:outerShdw blurRad="50800" dist="38100" dir="2700000" algn="tl" rotWithShape="0">
+              <a:srgbClr val="094A55">
+                <a:alpha val="90000"/>
+              </a:srgbClr>
+            </a:outerShdw>
+          </a:effectLst>
         </p:spPr>
         <p:txBody>
           <a:bodyPr wrap="square" lIns="152400" tIns="152400" rIns="152400" bIns="152400" rtlCol="0" anchor="t"/>
@@ -12266,6 +12627,13 @@
           <a:ln>
             <a:noFill/>
           </a:ln>
+          <a:effectLst>
+            <a:outerShdw blurRad="50800" dist="38100" dir="10800000" algn="r" rotWithShape="0">
+              <a:srgbClr val="094A55">
+                <a:alpha val="90000"/>
+              </a:srgbClr>
+            </a:outerShdw>
+          </a:effectLst>
         </p:spPr>
         <p:txBody>
           <a:bodyPr/>
@@ -12527,8 +12895,8 @@
         </p:nvSpPr>
         <p:spPr>
           <a:xfrm>
-            <a:off x="457200" y="850000"/>
-            <a:ext cx="8229600" cy="700000"/>
+            <a:off x="457200" y="849999"/>
+            <a:ext cx="8229600" cy="850001"/>
           </a:xfrm>
           <a:prstGeom prst="rect">
             <a:avLst/>
@@ -12575,6 +12943,13 @@
           <a:ln>
             <a:noFill/>
           </a:ln>
+          <a:effectLst>
+            <a:outerShdw blurRad="50800" dist="38100" dir="2700000" algn="tl" rotWithShape="0">
+              <a:srgbClr val="094A55">
+                <a:alpha val="90000"/>
+              </a:srgbClr>
+            </a:outerShdw>
+          </a:effectLst>
         </p:spPr>
         <p:txBody>
           <a:bodyPr wrap="square" lIns="228600" tIns="228600" rIns="228600" bIns="228600" rtlCol="0" anchor="t"/>
@@ -12650,6 +13025,13 @@
           <a:ln>
             <a:noFill/>
           </a:ln>
+          <a:effectLst>
+            <a:outerShdw blurRad="50800" dist="38100" dir="2700000" algn="tl" rotWithShape="0">
+              <a:srgbClr val="094A55">
+                <a:alpha val="90000"/>
+              </a:srgbClr>
+            </a:outerShdw>
+          </a:effectLst>
         </p:spPr>
         <p:txBody>
           <a:bodyPr wrap="square" lIns="228600" tIns="228600" rIns="228600" bIns="228600" rtlCol="0" anchor="t"/>
@@ -12790,6 +13172,13 @@
             <a:avLst/>
           </a:prstGeom>
           <a:noFill/>
+          <a:effectLst>
+            <a:outerShdw blurRad="50800" dist="38100" dir="2700000" algn="tl" rotWithShape="0">
+              <a:srgbClr val="094A55">
+                <a:alpha val="90000"/>
+              </a:srgbClr>
+            </a:outerShdw>
+          </a:effectLst>
         </p:spPr>
         <p:txBody>
           <a:bodyPr wrap="square" rtlCol="0" anchor="t"/>
@@ -12865,31 +13254,32 @@
           <a:ln>
             <a:noFill/>
           </a:ln>
+          <a:effectLst>
+            <a:outerShdw blurRad="50800" dist="38100" dir="2700000" algn="tl" rotWithShape="0">
+              <a:srgbClr val="094A55">
+                <a:alpha val="90000"/>
+              </a:srgbClr>
+            </a:outerShdw>
+          </a:effectLst>
         </p:spPr>
         <p:txBody>
-          <a:bodyPr wrap="square" lIns="228600" tIns="228600" rIns="228600" bIns="228600" rtlCol="0" anchor="t"/>
+          <a:bodyPr wrap="square" lIns="274320" tIns="228600" rIns="274320" bIns="228600" rtlCol="0" anchor="t"/>
           <a:lstStyle/>
           <a:p>
-            <a:pPr algn="l">
-              <a:buNone/>
-            </a:pPr>
-            <a:r>
-              <a:rPr lang="es-ES" sz="2000" b="1" dirty="0">
-                <a:solidFill>
-                  <a:schemeClr val="dk2"/>
+            <a:r>
+              <a:rPr lang="es-ES" sz="1300" b="1" dirty="0">
+                <a:solidFill>
+                  <a:schemeClr val="accent6"/>
                 </a:solidFill>
               </a:rPr>
               <a:t>Hiperlocal</a:t>
             </a:r>
           </a:p>
           <a:p>
-            <a:pPr algn="l">
-              <a:buNone/>
-            </a:pPr>
-            <a:r>
-              <a:rPr lang="es-ES" sz="1500" dirty="0">
-                <a:solidFill>
-                  <a:schemeClr val="dk1"/>
+            <a:r>
+              <a:rPr lang="es-ES" sz="1300" b="1" dirty="0">
+                <a:solidFill>
+                  <a:schemeClr val="accent6"/>
                 </a:solidFill>
               </a:rPr>
               <a:t>Conexión entre vecinos del mismo barrio, con publicaciones y categorías visuales.</a:t>
@@ -12919,31 +13309,32 @@
           <a:ln>
             <a:noFill/>
           </a:ln>
+          <a:effectLst>
+            <a:outerShdw blurRad="50800" dist="38100" dir="2700000" algn="tl" rotWithShape="0">
+              <a:srgbClr val="094A55">
+                <a:alpha val="90000"/>
+              </a:srgbClr>
+            </a:outerShdw>
+          </a:effectLst>
         </p:spPr>
         <p:txBody>
-          <a:bodyPr wrap="square" lIns="228600" tIns="228600" rIns="228600" bIns="228600" rtlCol="0" anchor="t"/>
+          <a:bodyPr wrap="square" lIns="274320" tIns="228600" rIns="274320" bIns="228600" rtlCol="0" anchor="t"/>
           <a:lstStyle/>
           <a:p>
-            <a:pPr algn="l">
-              <a:buNone/>
-            </a:pPr>
-            <a:r>
-              <a:rPr lang="es-ES" sz="2000" b="1" dirty="0">
-                <a:solidFill>
-                  <a:schemeClr val="dk2"/>
+            <a:r>
+              <a:rPr lang="es-ES" sz="1300" b="1" dirty="0">
+                <a:solidFill>
+                  <a:schemeClr val="accent6"/>
                 </a:solidFill>
               </a:rPr>
               <a:t>Banco de tiempo</a:t>
             </a:r>
           </a:p>
           <a:p>
-            <a:pPr algn="l">
-              <a:buNone/>
-            </a:pPr>
-            <a:r>
-              <a:rPr lang="es-ES" sz="1500" dirty="0">
-                <a:solidFill>
-                  <a:schemeClr val="dk1"/>
+            <a:r>
+              <a:rPr lang="es-ES" sz="1300" b="1" dirty="0">
+                <a:solidFill>
+                  <a:schemeClr val="accent6"/>
                 </a:solidFill>
               </a:rPr>
               <a:t>Una hora vale lo mismo para todos, sin dinero. Saldo inicial: 2h para empezar.</a:t>
@@ -12973,31 +13364,32 @@
           <a:ln>
             <a:noFill/>
           </a:ln>
+          <a:effectLst>
+            <a:outerShdw blurRad="50800" dist="38100" dir="2700000" algn="tl" rotWithShape="0">
+              <a:srgbClr val="094A55">
+                <a:alpha val="90000"/>
+              </a:srgbClr>
+            </a:outerShdw>
+          </a:effectLst>
         </p:spPr>
         <p:txBody>
-          <a:bodyPr wrap="square" lIns="228600" tIns="228600" rIns="228600" bIns="228600" rtlCol="0" anchor="t"/>
+          <a:bodyPr wrap="square" lIns="274320" tIns="228600" rIns="274320" bIns="228600" rtlCol="0" anchor="t"/>
           <a:lstStyle/>
           <a:p>
-            <a:pPr algn="l">
-              <a:buNone/>
-            </a:pPr>
-            <a:r>
-              <a:rPr lang="es-ES" sz="2000" b="1" dirty="0">
-                <a:solidFill>
-                  <a:schemeClr val="dk2"/>
+            <a:r>
+              <a:rPr lang="es-ES" sz="1300" b="1" dirty="0">
+                <a:solidFill>
+                  <a:schemeClr val="accent6"/>
                 </a:solidFill>
               </a:rPr>
               <a:t>Accesible</a:t>
             </a:r>
           </a:p>
           <a:p>
-            <a:pPr algn="l">
-              <a:buNone/>
-            </a:pPr>
-            <a:r>
-              <a:rPr lang="es-ES" sz="1500" dirty="0">
-                <a:solidFill>
-                  <a:schemeClr val="dk1"/>
+            <a:r>
+              <a:rPr lang="es-ES" sz="1300" b="1" dirty="0">
+                <a:solidFill>
+                  <a:schemeClr val="accent6"/>
                 </a:solidFill>
               </a:rPr>
               <a:t>TTS nativo + pictogramas ARASAAC. Accesibilidad activa, no pasiva.</a:t>
@@ -13084,6 +13476,13 @@
             <a:avLst/>
           </a:prstGeom>
           <a:noFill/>
+          <a:effectLst>
+            <a:outerShdw blurRad="50800" dist="38100" dir="2700000" algn="tl" rotWithShape="0">
+              <a:srgbClr val="094A55">
+                <a:alpha val="90000"/>
+              </a:srgbClr>
+            </a:outerShdw>
+          </a:effectLst>
         </p:spPr>
         <p:txBody>
           <a:bodyPr wrap="square" rtlCol="0" anchor="t"/>
@@ -13125,6 +13524,13 @@
           <a:ln>
             <a:noFill/>
           </a:ln>
+          <a:effectLst>
+            <a:outerShdw blurRad="50800" dist="38100" dir="2700000" algn="tl" rotWithShape="0">
+              <a:srgbClr val="094A55">
+                <a:alpha val="90000"/>
+              </a:srgbClr>
+            </a:outerShdw>
+          </a:effectLst>
         </p:spPr>
         <p:txBody>
           <a:bodyPr wrap="square" lIns="274320" tIns="182880" rIns="274320" bIns="182880" rtlCol="0" anchor="ctr"/>
@@ -13179,6 +13585,13 @@
           <a:ln>
             <a:noFill/>
           </a:ln>
+          <a:effectLst>
+            <a:outerShdw blurRad="50800" dist="38100" dir="2700000" algn="tl" rotWithShape="0">
+              <a:srgbClr val="094A55">
+                <a:alpha val="90000"/>
+              </a:srgbClr>
+            </a:outerShdw>
+          </a:effectLst>
         </p:spPr>
         <p:txBody>
           <a:bodyPr wrap="square" lIns="274320" tIns="182880" rIns="274320" bIns="182880" rtlCol="0" anchor="ctr"/>
@@ -13279,6 +13692,13 @@
             <a:avLst/>
           </a:prstGeom>
           <a:noFill/>
+          <a:effectLst>
+            <a:outerShdw blurRad="50800" dist="38100" dir="2700000" algn="tl" rotWithShape="0">
+              <a:srgbClr val="094A55">
+                <a:alpha val="90000"/>
+              </a:srgbClr>
+            </a:outerShdw>
+          </a:effectLst>
         </p:spPr>
         <p:txBody>
           <a:bodyPr wrap="square" rtlCol="0" anchor="t"/>
@@ -13320,6 +13740,13 @@
           <a:ln>
             <a:noFill/>
           </a:ln>
+          <a:effectLst>
+            <a:outerShdw blurRad="50800" dist="38100" dir="2700000" algn="tl" rotWithShape="0">
+              <a:srgbClr val="094A55">
+                <a:alpha val="90000"/>
+              </a:srgbClr>
+            </a:outerShdw>
+          </a:effectLst>
         </p:spPr>
         <p:txBody>
           <a:bodyPr wrap="square" lIns="152400" tIns="152400" rIns="152400" bIns="152400" rtlCol="0" anchor="t"/>
@@ -13387,6 +13814,13 @@
           <a:ln>
             <a:noFill/>
           </a:ln>
+          <a:effectLst>
+            <a:outerShdw blurRad="50800" dist="38100" dir="2700000" algn="tl" rotWithShape="0">
+              <a:srgbClr val="094A55">
+                <a:alpha val="90000"/>
+              </a:srgbClr>
+            </a:outerShdw>
+          </a:effectLst>
         </p:spPr>
         <p:txBody>
           <a:bodyPr wrap="square" lIns="152400" tIns="152400" rIns="152400" bIns="152400" rtlCol="0" anchor="t"/>
@@ -13454,6 +13888,13 @@
           <a:ln>
             <a:noFill/>
           </a:ln>
+          <a:effectLst>
+            <a:outerShdw blurRad="50800" dist="38100" dir="2700000" algn="tl" rotWithShape="0">
+              <a:srgbClr val="094A55">
+                <a:alpha val="90000"/>
+              </a:srgbClr>
+            </a:outerShdw>
+          </a:effectLst>
         </p:spPr>
         <p:txBody>
           <a:bodyPr wrap="square" lIns="152400" tIns="152400" rIns="152400" bIns="152400" rtlCol="0" anchor="t"/>
@@ -13521,6 +13962,13 @@
           <a:ln>
             <a:noFill/>
           </a:ln>
+          <a:effectLst>
+            <a:outerShdw blurRad="50800" dist="38100" dir="2700000" algn="tl" rotWithShape="0">
+              <a:srgbClr val="094A55">
+                <a:alpha val="90000"/>
+              </a:srgbClr>
+            </a:outerShdw>
+          </a:effectLst>
         </p:spPr>
         <p:txBody>
           <a:bodyPr wrap="square" lIns="152400" tIns="152400" rIns="152400" bIns="152400" rtlCol="0" anchor="t"/>
@@ -13588,6 +14036,13 @@
           <a:ln>
             <a:noFill/>
           </a:ln>
+          <a:effectLst>
+            <a:outerShdw blurRad="50800" dist="38100" dir="2700000" algn="tl" rotWithShape="0">
+              <a:srgbClr val="094A55">
+                <a:alpha val="90000"/>
+              </a:srgbClr>
+            </a:outerShdw>
+          </a:effectLst>
         </p:spPr>
         <p:txBody>
           <a:bodyPr wrap="square" lIns="152400" tIns="152400" rIns="152400" bIns="152400" rtlCol="0" anchor="t"/>
@@ -13655,6 +14110,13 @@
           <a:ln>
             <a:noFill/>
           </a:ln>
+          <a:effectLst>
+            <a:outerShdw blurRad="50800" dist="38100" dir="2700000" algn="tl" rotWithShape="0">
+              <a:srgbClr val="094A55">
+                <a:alpha val="90000"/>
+              </a:srgbClr>
+            </a:outerShdw>
+          </a:effectLst>
         </p:spPr>
         <p:txBody>
           <a:bodyPr wrap="square" lIns="152400" tIns="152400" rIns="152400" bIns="152400" rtlCol="0" anchor="t"/>
@@ -13722,6 +14184,13 @@
           <a:ln>
             <a:noFill/>
           </a:ln>
+          <a:effectLst>
+            <a:outerShdw blurRad="50800" dist="38100" dir="2700000" algn="tl" rotWithShape="0">
+              <a:srgbClr val="094A55">
+                <a:alpha val="90000"/>
+              </a:srgbClr>
+            </a:outerShdw>
+          </a:effectLst>
         </p:spPr>
         <p:txBody>
           <a:bodyPr wrap="square" lIns="152400" tIns="152400" rIns="152400" bIns="152400" rtlCol="0" anchor="t"/>
@@ -13789,6 +14258,13 @@
           <a:ln>
             <a:noFill/>
           </a:ln>
+          <a:effectLst>
+            <a:outerShdw blurRad="50800" dist="38100" dir="2700000" algn="tl" rotWithShape="0">
+              <a:srgbClr val="094A55">
+                <a:alpha val="90000"/>
+              </a:srgbClr>
+            </a:outerShdw>
+          </a:effectLst>
         </p:spPr>
         <p:txBody>
           <a:bodyPr wrap="square" lIns="152400" tIns="152400" rIns="152400" bIns="152400" rtlCol="0" anchor="t"/>
@@ -13913,6 +14389,13 @@
             <a:avLst/>
           </a:prstGeom>
           <a:noFill/>
+          <a:effectLst>
+            <a:outerShdw blurRad="50800" dist="38100" dir="2700000" algn="tl" rotWithShape="0">
+              <a:srgbClr val="094A55">
+                <a:alpha val="90000"/>
+              </a:srgbClr>
+            </a:outerShdw>
+          </a:effectLst>
         </p:spPr>
         <p:txBody>
           <a:bodyPr wrap="square" rtlCol="0" anchor="t"/>
@@ -13954,6 +14437,13 @@
           <a:ln>
             <a:noFill/>
           </a:ln>
+          <a:effectLst>
+            <a:outerShdw blurRad="50800" dist="38100" dir="2700000" algn="tl" rotWithShape="0">
+              <a:srgbClr val="094A55">
+                <a:alpha val="90000"/>
+              </a:srgbClr>
+            </a:outerShdw>
+          </a:effectLst>
         </p:spPr>
         <p:txBody>
           <a:bodyPr wrap="square" lIns="274320" tIns="228600" rIns="274320" bIns="228600" rtlCol="0" anchor="t"/>
@@ -14047,6 +14537,13 @@
           <a:ln>
             <a:noFill/>
           </a:ln>
+          <a:effectLst>
+            <a:outerShdw blurRad="50800" dist="38100" dir="2700000" algn="tl" rotWithShape="0">
+              <a:srgbClr val="094A55">
+                <a:alpha val="90000"/>
+              </a:srgbClr>
+            </a:outerShdw>
+          </a:effectLst>
         </p:spPr>
         <p:txBody>
           <a:bodyPr wrap="square" lIns="274320" tIns="228600" rIns="274320" bIns="228600" rtlCol="0" anchor="t"/>
@@ -14334,6 +14831,13 @@
           <a:ln>
             <a:noFill/>
           </a:ln>
+          <a:effectLst>
+            <a:outerShdw blurRad="50800" dist="38100" dir="2700000" algn="tl" rotWithShape="0">
+              <a:srgbClr val="094A55">
+                <a:alpha val="90000"/>
+              </a:srgbClr>
+            </a:outerShdw>
+          </a:effectLst>
         </p:spPr>
         <p:txBody>
           <a:bodyPr wrap="square" lIns="228600" tIns="182880" rIns="228600" bIns="182880" rtlCol="0" anchor="t"/>
@@ -14414,6 +14918,13 @@
           <a:ln>
             <a:noFill/>
           </a:ln>
+          <a:effectLst>
+            <a:outerShdw blurRad="50800" dist="38100" dir="2700000" algn="tl" rotWithShape="0">
+              <a:srgbClr val="094A55">
+                <a:alpha val="90000"/>
+              </a:srgbClr>
+            </a:outerShdw>
+          </a:effectLst>
         </p:spPr>
         <p:txBody>
           <a:bodyPr wrap="square" lIns="228600" tIns="182880" rIns="228600" bIns="182880" rtlCol="0" anchor="t"/>
@@ -14494,6 +15005,13 @@
           <a:ln>
             <a:noFill/>
           </a:ln>
+          <a:effectLst>
+            <a:outerShdw blurRad="50800" dist="38100" dir="2700000" algn="tl" rotWithShape="0">
+              <a:srgbClr val="094A55">
+                <a:alpha val="90000"/>
+              </a:srgbClr>
+            </a:outerShdw>
+          </a:effectLst>
         </p:spPr>
         <p:txBody>
           <a:bodyPr wrap="square" lIns="228600" tIns="182880" rIns="228600" bIns="182880" rtlCol="0" anchor="t"/>
@@ -14574,6 +15092,13 @@
           <a:ln>
             <a:noFill/>
           </a:ln>
+          <a:effectLst>
+            <a:outerShdw blurRad="50800" dist="38100" dir="2700000" algn="tl" rotWithShape="0">
+              <a:srgbClr val="094A55">
+                <a:alpha val="90000"/>
+              </a:srgbClr>
+            </a:outerShdw>
+          </a:effectLst>
         </p:spPr>
         <p:txBody>
           <a:bodyPr wrap="square" lIns="228600" tIns="182880" rIns="228600" bIns="182880" rtlCol="0" anchor="t"/>
@@ -14711,6 +15236,13 @@
             <a:avLst/>
           </a:prstGeom>
           <a:noFill/>
+          <a:effectLst>
+            <a:outerShdw blurRad="50800" dist="38100" dir="2700000" algn="tl" rotWithShape="0">
+              <a:srgbClr val="094A55">
+                <a:alpha val="90000"/>
+              </a:srgbClr>
+            </a:outerShdw>
+          </a:effectLst>
         </p:spPr>
         <p:txBody>
           <a:bodyPr wrap="square" rtlCol="0" anchor="t"/>

</xml_diff>